<commit_message>
update decaf intro for llvm 20
</commit_message>
<xml_diff>
--- a/assets/ppt/codegen/decafLLVM.pptx
+++ b/assets/ppt/codegen/decafLLVM.pptx
@@ -268,7 +268,7 @@
                 <a:latin typeface="Calibri" panose="020F0502020204030204" pitchFamily="34" charset="0"/>
               </a:rPr>
               <a:pPr/>
-              <a:t>11/15/21</a:t>
+              <a:t>6/30/25</a:t>
             </a:fld>
             <a:endParaRPr lang="en-US" dirty="0">
               <a:latin typeface="Calibri" panose="020F0502020204030204" pitchFamily="34" charset="0"/>
@@ -953,7 +953,7 @@
           <a:p>
             <a:fld id="{1B6DC762-1116-2146-A47C-D79A5A5DBAFD}" type="datetime1">
               <a:rPr lang="en-CA" smtClean="0"/>
-              <a:t>2021-11-15</a:t>
+              <a:t>2025-06-30</a:t>
             </a:fld>
             <a:endParaRPr lang="en-US"/>
           </a:p>
@@ -1151,7 +1151,7 @@
           <a:p>
             <a:fld id="{725FEDD1-5A1B-2342-BAF0-F7C5511A73CE}" type="datetime1">
               <a:rPr lang="en-CA" smtClean="0"/>
-              <a:t>2021-11-15</a:t>
+              <a:t>2025-06-30</a:t>
             </a:fld>
             <a:endParaRPr lang="en-US"/>
           </a:p>
@@ -1359,7 +1359,7 @@
           <a:p>
             <a:fld id="{F09E59AE-0AE1-4048-8BD6-D39FC0EBB194}" type="datetime1">
               <a:rPr lang="en-CA" smtClean="0"/>
-              <a:t>2021-11-15</a:t>
+              <a:t>2025-06-30</a:t>
             </a:fld>
             <a:endParaRPr lang="en-US"/>
           </a:p>
@@ -2834,7 +2834,7 @@
           <a:p>
             <a:fld id="{A2849525-9B7D-5945-A782-775278635E42}" type="datetime1">
               <a:rPr lang="en-CA" smtClean="0"/>
-              <a:t>2021-11-15</a:t>
+              <a:t>2025-06-30</a:t>
             </a:fld>
             <a:endParaRPr lang="en-US"/>
           </a:p>
@@ -3109,7 +3109,7 @@
           <a:p>
             <a:fld id="{D05E1499-BDD1-6940-8C79-13A8B8E63D57}" type="datetime1">
               <a:rPr lang="en-CA" smtClean="0"/>
-              <a:t>2021-11-15</a:t>
+              <a:t>2025-06-30</a:t>
             </a:fld>
             <a:endParaRPr lang="en-US"/>
           </a:p>
@@ -3374,7 +3374,7 @@
           <a:p>
             <a:fld id="{17E70EF3-18A7-4644-8DA2-1EB9CA66C736}" type="datetime1">
               <a:rPr lang="en-CA" smtClean="0"/>
-              <a:t>2021-11-15</a:t>
+              <a:t>2025-06-30</a:t>
             </a:fld>
             <a:endParaRPr lang="en-US"/>
           </a:p>
@@ -3786,7 +3786,7 @@
           <a:p>
             <a:fld id="{54538FC1-2481-FB4A-91E5-87F3422DE2D5}" type="datetime1">
               <a:rPr lang="en-CA" smtClean="0"/>
-              <a:t>2021-11-15</a:t>
+              <a:t>2025-06-30</a:t>
             </a:fld>
             <a:endParaRPr lang="en-US"/>
           </a:p>
@@ -3927,7 +3927,7 @@
           <a:p>
             <a:fld id="{93D5C515-1622-C840-89B2-A4A55D34866A}" type="datetime1">
               <a:rPr lang="en-CA" smtClean="0"/>
-              <a:t>2021-11-15</a:t>
+              <a:t>2025-06-30</a:t>
             </a:fld>
             <a:endParaRPr lang="en-US"/>
           </a:p>
@@ -4040,7 +4040,7 @@
           <a:p>
             <a:fld id="{B9077E75-6C88-BB47-AC6F-0DCA859E7113}" type="datetime1">
               <a:rPr lang="en-CA" smtClean="0"/>
-              <a:t>2021-11-15</a:t>
+              <a:t>2025-06-30</a:t>
             </a:fld>
             <a:endParaRPr lang="en-US"/>
           </a:p>
@@ -4351,7 +4351,7 @@
           <a:p>
             <a:fld id="{1AD12F8B-7E05-A047-BAC3-EE71BEBBE5BE}" type="datetime1">
               <a:rPr lang="en-CA" smtClean="0"/>
-              <a:t>2021-11-15</a:t>
+              <a:t>2025-06-30</a:t>
             </a:fld>
             <a:endParaRPr lang="en-US"/>
           </a:p>
@@ -4639,7 +4639,7 @@
           <a:p>
             <a:fld id="{C1D9F72A-E93E-B546-8268-6408A6E1DA62}" type="datetime1">
               <a:rPr lang="en-CA" smtClean="0"/>
-              <a:t>2021-11-15</a:t>
+              <a:t>2025-06-30</a:t>
             </a:fld>
             <a:endParaRPr lang="en-US"/>
           </a:p>
@@ -4882,7 +4882,7 @@
             <a:fld id="{97DF4AC7-DB73-7444-A2A7-FD79FE1A2B2B}" type="datetime1">
               <a:rPr lang="en-CA" smtClean="0"/>
               <a:pPr/>
-              <a:t>2021-11-15</a:t>
+              <a:t>2025-06-30</a:t>
             </a:fld>
             <a:endParaRPr lang="en-US" dirty="0"/>
           </a:p>
@@ -13881,8 +13881,8 @@
         </p:nvSpPr>
         <p:spPr>
           <a:xfrm>
-            <a:off x="755576" y="1419622"/>
-            <a:ext cx="5610190" cy="3139321"/>
+            <a:off x="334686" y="1498174"/>
+            <a:ext cx="8474628" cy="2862322"/>
           </a:xfrm>
           <a:prstGeom prst="rect">
             <a:avLst/>
@@ -13929,39 +13929,67 @@
               <a:rPr lang="en-US" sz="2000" dirty="0">
                 <a:latin typeface="Calibri" panose="020F0502020204030204" pitchFamily="34" charset="0"/>
               </a:rPr>
-              <a:t> </a:t>
+              <a:t> ty) {</a:t>
+            </a:r>
+          </a:p>
+          <a:p>
+            <a:r>
+              <a:rPr lang="en-US" sz="2000" dirty="0">
+                <a:latin typeface="Calibri" panose="020F0502020204030204" pitchFamily="34" charset="0"/>
+              </a:rPr>
+              <a:t>        switch (ty) {</a:t>
+            </a:r>
+          </a:p>
+          <a:p>
+            <a:r>
+              <a:rPr lang="en-US" sz="2000" dirty="0">
+                <a:latin typeface="Calibri" panose="020F0502020204030204" pitchFamily="34" charset="0"/>
+              </a:rPr>
+              <a:t>                case </a:t>
             </a:r>
             <a:r>
               <a:rPr lang="en-US" sz="2000" dirty="0" err="1">
                 <a:latin typeface="Calibri" panose="020F0502020204030204" pitchFamily="34" charset="0"/>
               </a:rPr>
-              <a:t>ty</a:t>
+              <a:t>voidTy</a:t>
             </a:r>
             <a:r>
               <a:rPr lang="en-US" sz="2000" dirty="0">
                 <a:latin typeface="Calibri" panose="020F0502020204030204" pitchFamily="34" charset="0"/>
               </a:rPr>
-              <a:t>) {</a:t>
-            </a:r>
-          </a:p>
-          <a:p>
+              <a:t>: return </a:t>
+            </a:r>
+            <a:r>
+              <a:rPr lang="en-US" sz="2000" dirty="0" err="1">
+                <a:latin typeface="Calibri" panose="020F0502020204030204" pitchFamily="34" charset="0"/>
+              </a:rPr>
+              <a:t>Builder.getVoidTy</a:t>
+            </a:r>
             <a:r>
               <a:rPr lang="en-US" sz="2000" dirty="0">
                 <a:latin typeface="Calibri" panose="020F0502020204030204" pitchFamily="34" charset="0"/>
               </a:rPr>
-              <a:t>    switch (</a:t>
+              <a:t>();</a:t>
+            </a:r>
+          </a:p>
+          <a:p>
+            <a:r>
+              <a:rPr lang="en-US" sz="2000" dirty="0">
+                <a:latin typeface="Calibri" panose="020F0502020204030204" pitchFamily="34" charset="0"/>
+              </a:rPr>
+              <a:t>                case </a:t>
             </a:r>
             <a:r>
               <a:rPr lang="en-US" sz="2000" dirty="0" err="1">
                 <a:latin typeface="Calibri" panose="020F0502020204030204" pitchFamily="34" charset="0"/>
               </a:rPr>
-              <a:t>ty</a:t>
+              <a:t>intTy</a:t>
             </a:r>
             <a:r>
               <a:rPr lang="en-US" sz="2000" dirty="0">
                 <a:latin typeface="Calibri" panose="020F0502020204030204" pitchFamily="34" charset="0"/>
               </a:rPr>
-              <a:t>) {</a:t>
+              <a:t>: return Builder.getInt32Ty();</a:t>
             </a:r>
           </a:p>
           <a:p>
@@ -13969,51 +13997,75 @@
               <a:rPr lang="en-US" sz="2000" dirty="0">
                 <a:latin typeface="Calibri" panose="020F0502020204030204" pitchFamily="34" charset="0"/>
               </a:rPr>
-              <a:t>        case </a:t>
+              <a:t>                case </a:t>
             </a:r>
             <a:r>
               <a:rPr lang="en-US" sz="2000" dirty="0" err="1">
                 <a:latin typeface="Calibri" panose="020F0502020204030204" pitchFamily="34" charset="0"/>
               </a:rPr>
-              <a:t>voidTy</a:t>
+              <a:t>boolTy</a:t>
             </a:r>
             <a:r>
               <a:rPr lang="en-US" sz="2000" dirty="0">
                 <a:latin typeface="Calibri" panose="020F0502020204030204" pitchFamily="34" charset="0"/>
               </a:rPr>
+              <a:t>: return Builder.getInt1Ty();</a:t>
+            </a:r>
+          </a:p>
+          <a:p>
+            <a:r>
+              <a:rPr lang="en-US" sz="2000" dirty="0">
+                <a:latin typeface="Calibri" panose="020F0502020204030204" pitchFamily="34" charset="0"/>
+              </a:rPr>
+              <a:t>                case </a:t>
+            </a:r>
+            <a:r>
+              <a:rPr lang="en-US" sz="2000" dirty="0" err="1">
+                <a:latin typeface="Calibri" panose="020F0502020204030204" pitchFamily="34" charset="0"/>
+              </a:rPr>
+              <a:t>stringTy</a:t>
+            </a:r>
+            <a:r>
+              <a:rPr lang="en-US" sz="2000" dirty="0">
+                <a:latin typeface="Calibri" panose="020F0502020204030204" pitchFamily="34" charset="0"/>
+              </a:rPr>
               <a:t>: return </a:t>
             </a:r>
             <a:r>
               <a:rPr lang="en-US" sz="2000" dirty="0" err="1">
                 <a:latin typeface="Calibri" panose="020F0502020204030204" pitchFamily="34" charset="0"/>
               </a:rPr>
-              <a:t>Builder.getVoidTy</a:t>
+              <a:t>llvm</a:t>
             </a:r>
             <a:r>
               <a:rPr lang="en-US" sz="2000" dirty="0">
                 <a:latin typeface="Calibri" panose="020F0502020204030204" pitchFamily="34" charset="0"/>
               </a:rPr>
-              <a:t>();</a:t>
-            </a:r>
-          </a:p>
-          <a:p>
+              <a:t>::</a:t>
+            </a:r>
+            <a:r>
+              <a:rPr lang="en-US" sz="2000" dirty="0" err="1">
+                <a:latin typeface="Calibri" panose="020F0502020204030204" pitchFamily="34" charset="0"/>
+              </a:rPr>
+              <a:t>PointerType</a:t>
+            </a:r>
             <a:r>
               <a:rPr lang="en-US" sz="2000" dirty="0">
                 <a:latin typeface="Calibri" panose="020F0502020204030204" pitchFamily="34" charset="0"/>
               </a:rPr>
-              <a:t>        case </a:t>
+              <a:t>::</a:t>
             </a:r>
             <a:r>
               <a:rPr lang="en-US" sz="2000" dirty="0" err="1">
                 <a:latin typeface="Calibri" panose="020F0502020204030204" pitchFamily="34" charset="0"/>
               </a:rPr>
-              <a:t>intTy</a:t>
+              <a:t>getUnqual</a:t>
             </a:r>
             <a:r>
               <a:rPr lang="en-US" sz="2000" dirty="0">
                 <a:latin typeface="Calibri" panose="020F0502020204030204" pitchFamily="34" charset="0"/>
               </a:rPr>
-              <a:t>: return Builder.getInt32Ty();</a:t>
+              <a:t>(Builder.getInt8Ty());</a:t>
             </a:r>
           </a:p>
           <a:p>
@@ -14021,39 +14073,39 @@
               <a:rPr lang="en-US" sz="2000" dirty="0">
                 <a:latin typeface="Calibri" panose="020F0502020204030204" pitchFamily="34" charset="0"/>
               </a:rPr>
-              <a:t>        case </a:t>
+              <a:t>                default: throw </a:t>
             </a:r>
             <a:r>
               <a:rPr lang="en-US" sz="2000" dirty="0" err="1">
                 <a:latin typeface="Calibri" panose="020F0502020204030204" pitchFamily="34" charset="0"/>
               </a:rPr>
-              <a:t>boolTy</a:t>
+              <a:t>runtime_error</a:t>
             </a:r>
             <a:r>
               <a:rPr lang="en-US" sz="2000" dirty="0">
                 <a:latin typeface="Calibri" panose="020F0502020204030204" pitchFamily="34" charset="0"/>
               </a:rPr>
-              <a:t>: return Builder.getInt1Ty();</a:t>
-            </a:r>
-          </a:p>
-          <a:p>
+              <a:t>("unknown type in </a:t>
+            </a:r>
+            <a:r>
+              <a:rPr lang="en-US" sz="2000" dirty="0" err="1">
+                <a:latin typeface="Calibri" panose="020F0502020204030204" pitchFamily="34" charset="0"/>
+              </a:rPr>
+              <a:t>getType</a:t>
+            </a:r>
             <a:r>
               <a:rPr lang="en-US" sz="2000" dirty="0">
                 <a:latin typeface="Calibri" panose="020F0502020204030204" pitchFamily="34" charset="0"/>
               </a:rPr>
-              <a:t>        case </a:t>
-            </a:r>
-            <a:r>
-              <a:rPr lang="en-US" sz="2000" dirty="0" err="1">
-                <a:latin typeface="Calibri" panose="020F0502020204030204" pitchFamily="34" charset="0"/>
-              </a:rPr>
-              <a:t>stringTy</a:t>
-            </a:r>
+              <a:t> call");</a:t>
+            </a:r>
+          </a:p>
+          <a:p>
             <a:r>
               <a:rPr lang="en-US" sz="2000" dirty="0">
                 <a:latin typeface="Calibri" panose="020F0502020204030204" pitchFamily="34" charset="0"/>
               </a:rPr>
-              <a:t>: return Builder.getInt8PtrTy();</a:t>
+              <a:t>        }</a:t>
             </a:r>
           </a:p>
           <a:p>
@@ -14061,38 +14113,8 @@
               <a:rPr lang="en-US" sz="2000" dirty="0">
                 <a:latin typeface="Calibri" panose="020F0502020204030204" pitchFamily="34" charset="0"/>
               </a:rPr>
-              <a:t>        default: throw </a:t>
-            </a:r>
-            <a:r>
-              <a:rPr lang="en-US" sz="2000" dirty="0" err="1">
-                <a:latin typeface="Calibri" panose="020F0502020204030204" pitchFamily="34" charset="0"/>
-              </a:rPr>
-              <a:t>runtime_error</a:t>
-            </a:r>
-            <a:r>
-              <a:rPr lang="en-US" sz="2000" dirty="0">
-                <a:latin typeface="Calibri" panose="020F0502020204030204" pitchFamily="34" charset="0"/>
-              </a:rPr>
-              <a:t>("unknown type");</a:t>
-            </a:r>
-          </a:p>
-          <a:p>
-            <a:r>
-              <a:rPr lang="en-US" sz="2000" dirty="0">
-                <a:latin typeface="Calibri" panose="020F0502020204030204" pitchFamily="34" charset="0"/>
-              </a:rPr>
-              <a:t>    }   </a:t>
-            </a:r>
-          </a:p>
-          <a:p>
-            <a:r>
-              <a:rPr lang="en-US" sz="2000" dirty="0">
-                <a:latin typeface="Calibri" panose="020F0502020204030204" pitchFamily="34" charset="0"/>
-              </a:rPr>
               <a:t>}</a:t>
             </a:r>
-          </a:p>
-          <a:p>
             <a:endParaRPr lang="en-US" sz="1800" dirty="0">
               <a:latin typeface="Calibri" panose="020F0502020204030204" pitchFamily="34" charset="0"/>
             </a:endParaRPr>
@@ -15853,8 +15875,8 @@
         </p:nvSpPr>
         <p:spPr>
           <a:xfrm>
-            <a:off x="4187086" y="3017155"/>
-            <a:ext cx="4489369" cy="576065"/>
+            <a:off x="4187086" y="3017156"/>
+            <a:ext cx="4705394" cy="576064"/>
           </a:xfrm>
           <a:prstGeom prst="wedgeRectCallout">
             <a:avLst>
@@ -15943,42 +15965,56 @@
                 <a:latin typeface="Consolas" panose="020B0609020204030204" pitchFamily="49" charset="0"/>
                 <a:cs typeface="Consolas" panose="020B0609020204030204" pitchFamily="49" charset="0"/>
               </a:rPr>
-              <a:t>rvalue</a:t>
+              <a:t>llvm</a:t>
             </a:r>
             <a:r>
               <a:rPr lang="en-US" sz="1800" dirty="0">
                 <a:latin typeface="Consolas" panose="020B0609020204030204" pitchFamily="49" charset="0"/>
                 <a:cs typeface="Consolas" panose="020B0609020204030204" pitchFamily="49" charset="0"/>
               </a:rPr>
-              <a:t>-&gt;</a:t>
+              <a:t>::</a:t>
             </a:r>
             <a:r>
               <a:rPr lang="en-US" sz="1800" dirty="0" err="1">
                 <a:latin typeface="Consolas" panose="020B0609020204030204" pitchFamily="49" charset="0"/>
                 <a:cs typeface="Consolas" panose="020B0609020204030204" pitchFamily="49" charset="0"/>
               </a:rPr>
-              <a:t>getType</a:t>
+              <a:t>PointerType</a:t>
             </a:r>
             <a:r>
               <a:rPr lang="en-US" sz="1800" dirty="0">
                 <a:latin typeface="Consolas" panose="020B0609020204030204" pitchFamily="49" charset="0"/>
                 <a:cs typeface="Consolas" panose="020B0609020204030204" pitchFamily="49" charset="0"/>
               </a:rPr>
-              <a:t>()-&gt;</a:t>
+              <a:t>::</a:t>
             </a:r>
             <a:r>
               <a:rPr lang="en-US" sz="1800" dirty="0" err="1">
                 <a:latin typeface="Consolas" panose="020B0609020204030204" pitchFamily="49" charset="0"/>
                 <a:cs typeface="Consolas" panose="020B0609020204030204" pitchFamily="49" charset="0"/>
               </a:rPr>
-              <a:t>getPointerTo</a:t>
+              <a:t>getUnqual</a:t>
             </a:r>
             <a:r>
               <a:rPr lang="en-US" sz="1800" dirty="0">
                 <a:latin typeface="Consolas" panose="020B0609020204030204" pitchFamily="49" charset="0"/>
                 <a:cs typeface="Consolas" panose="020B0609020204030204" pitchFamily="49" charset="0"/>
               </a:rPr>
-              <a:t>();</a:t>
+              <a:t>(</a:t>
+            </a:r>
+            <a:r>
+              <a:rPr lang="en-US" sz="1800" dirty="0" err="1">
+                <a:latin typeface="Consolas" panose="020B0609020204030204" pitchFamily="49" charset="0"/>
+                <a:cs typeface="Consolas" panose="020B0609020204030204" pitchFamily="49" charset="0"/>
+              </a:rPr>
+              <a:t>getTy</a:t>
+            </a:r>
+            <a:r>
+              <a:rPr lang="en-US" sz="1800" dirty="0">
+                <a:latin typeface="Consolas" panose="020B0609020204030204" pitchFamily="49" charset="0"/>
+                <a:cs typeface="Consolas" panose="020B0609020204030204" pitchFamily="49" charset="0"/>
+              </a:rPr>
+              <a:t>);</a:t>
             </a:r>
           </a:p>
         </p:txBody>

</xml_diff>

<commit_message>
update decafllvm and sem1 slides
</commit_message>
<xml_diff>
--- a/assets/ppt/codegen/decafLLVM.pptx
+++ b/assets/ppt/codegen/decafLLVM.pptx
@@ -268,7 +268,7 @@
                 <a:latin typeface="Calibri" panose="020F0502020204030204" pitchFamily="34" charset="0"/>
               </a:rPr>
               <a:pPr/>
-              <a:t>6/30/25</a:t>
+              <a:t>7/2/25</a:t>
             </a:fld>
             <a:endParaRPr lang="en-US" dirty="0">
               <a:latin typeface="Calibri" panose="020F0502020204030204" pitchFamily="34" charset="0"/>
@@ -953,7 +953,7 @@
           <a:p>
             <a:fld id="{1B6DC762-1116-2146-A47C-D79A5A5DBAFD}" type="datetime1">
               <a:rPr lang="en-CA" smtClean="0"/>
-              <a:t>2025-06-30</a:t>
+              <a:t>2025-07-02</a:t>
             </a:fld>
             <a:endParaRPr lang="en-US"/>
           </a:p>
@@ -1151,7 +1151,7 @@
           <a:p>
             <a:fld id="{725FEDD1-5A1B-2342-BAF0-F7C5511A73CE}" type="datetime1">
               <a:rPr lang="en-CA" smtClean="0"/>
-              <a:t>2025-06-30</a:t>
+              <a:t>2025-07-02</a:t>
             </a:fld>
             <a:endParaRPr lang="en-US"/>
           </a:p>
@@ -1359,7 +1359,7 @@
           <a:p>
             <a:fld id="{F09E59AE-0AE1-4048-8BD6-D39FC0EBB194}" type="datetime1">
               <a:rPr lang="en-CA" smtClean="0"/>
-              <a:t>2025-06-30</a:t>
+              <a:t>2025-07-02</a:t>
             </a:fld>
             <a:endParaRPr lang="en-US"/>
           </a:p>
@@ -2834,7 +2834,7 @@
           <a:p>
             <a:fld id="{A2849525-9B7D-5945-A782-775278635E42}" type="datetime1">
               <a:rPr lang="en-CA" smtClean="0"/>
-              <a:t>2025-06-30</a:t>
+              <a:t>2025-07-02</a:t>
             </a:fld>
             <a:endParaRPr lang="en-US"/>
           </a:p>
@@ -3109,7 +3109,7 @@
           <a:p>
             <a:fld id="{D05E1499-BDD1-6940-8C79-13A8B8E63D57}" type="datetime1">
               <a:rPr lang="en-CA" smtClean="0"/>
-              <a:t>2025-06-30</a:t>
+              <a:t>2025-07-02</a:t>
             </a:fld>
             <a:endParaRPr lang="en-US"/>
           </a:p>
@@ -3374,7 +3374,7 @@
           <a:p>
             <a:fld id="{17E70EF3-18A7-4644-8DA2-1EB9CA66C736}" type="datetime1">
               <a:rPr lang="en-CA" smtClean="0"/>
-              <a:t>2025-06-30</a:t>
+              <a:t>2025-07-02</a:t>
             </a:fld>
             <a:endParaRPr lang="en-US"/>
           </a:p>
@@ -3786,7 +3786,7 @@
           <a:p>
             <a:fld id="{54538FC1-2481-FB4A-91E5-87F3422DE2D5}" type="datetime1">
               <a:rPr lang="en-CA" smtClean="0"/>
-              <a:t>2025-06-30</a:t>
+              <a:t>2025-07-02</a:t>
             </a:fld>
             <a:endParaRPr lang="en-US"/>
           </a:p>
@@ -3927,7 +3927,7 @@
           <a:p>
             <a:fld id="{93D5C515-1622-C840-89B2-A4A55D34866A}" type="datetime1">
               <a:rPr lang="en-CA" smtClean="0"/>
-              <a:t>2025-06-30</a:t>
+              <a:t>2025-07-02</a:t>
             </a:fld>
             <a:endParaRPr lang="en-US"/>
           </a:p>
@@ -4040,7 +4040,7 @@
           <a:p>
             <a:fld id="{B9077E75-6C88-BB47-AC6F-0DCA859E7113}" type="datetime1">
               <a:rPr lang="en-CA" smtClean="0"/>
-              <a:t>2025-06-30</a:t>
+              <a:t>2025-07-02</a:t>
             </a:fld>
             <a:endParaRPr lang="en-US"/>
           </a:p>
@@ -4351,7 +4351,7 @@
           <a:p>
             <a:fld id="{1AD12F8B-7E05-A047-BAC3-EE71BEBBE5BE}" type="datetime1">
               <a:rPr lang="en-CA" smtClean="0"/>
-              <a:t>2025-06-30</a:t>
+              <a:t>2025-07-02</a:t>
             </a:fld>
             <a:endParaRPr lang="en-US"/>
           </a:p>
@@ -4639,7 +4639,7 @@
           <a:p>
             <a:fld id="{C1D9F72A-E93E-B546-8268-6408A6E1DA62}" type="datetime1">
               <a:rPr lang="en-CA" smtClean="0"/>
-              <a:t>2025-06-30</a:t>
+              <a:t>2025-07-02</a:t>
             </a:fld>
             <a:endParaRPr lang="en-US"/>
           </a:p>
@@ -4882,7 +4882,7 @@
             <a:fld id="{97DF4AC7-DB73-7444-A2A7-FD79FE1A2B2B}" type="datetime1">
               <a:rPr lang="en-CA" smtClean="0"/>
               <a:pPr/>
-              <a:t>2025-06-30</a:t>
+              <a:t>2025-07-02</a:t>
             </a:fld>
             <a:endParaRPr lang="en-US" dirty="0"/>
           </a:p>
@@ -14660,6 +14660,57 @@
           </a:p>
         </p:txBody>
       </p:sp>
+      <p:sp>
+        <p:nvSpPr>
+          <p:cNvPr id="8" name="Rectangular Callout 7">
+            <a:extLst>
+              <a:ext uri="{FF2B5EF4-FFF2-40B4-BE49-F238E27FC236}">
+                <a16:creationId xmlns:a16="http://schemas.microsoft.com/office/drawing/2014/main" id="{C8E24BBC-C94C-371D-1835-0D0844257B02}"/>
+              </a:ext>
+            </a:extLst>
+          </p:cNvPr>
+          <p:cNvSpPr/>
+          <p:nvPr/>
+        </p:nvSpPr>
+        <p:spPr>
+          <a:xfrm>
+            <a:off x="1043609" y="4445525"/>
+            <a:ext cx="5616623" cy="697975"/>
+          </a:xfrm>
+          <a:prstGeom prst="wedgeRectCallout">
+            <a:avLst>
+              <a:gd name="adj1" fmla="val -22910"/>
+              <a:gd name="adj2" fmla="val -62065"/>
+            </a:avLst>
+          </a:prstGeom>
+        </p:spPr>
+        <p:style>
+          <a:lnRef idx="2">
+            <a:schemeClr val="accent1">
+              <a:shade val="50000"/>
+            </a:schemeClr>
+          </a:lnRef>
+          <a:fillRef idx="1">
+            <a:schemeClr val="accent1"/>
+          </a:fillRef>
+          <a:effectRef idx="0">
+            <a:schemeClr val="accent1"/>
+          </a:effectRef>
+          <a:fontRef idx="minor">
+            <a:schemeClr val="lt1"/>
+          </a:fontRef>
+        </p:style>
+        <p:txBody>
+          <a:bodyPr rtlCol="0" anchor="ctr"/>
+          <a:lstStyle/>
+          <a:p>
+            <a:r>
+              <a:rPr lang="en-US" sz="1800" dirty="0"/>
+              <a:t>GEP stands for Get Element Pointer, which is used to get a pointer to array like objects in memory (more later)</a:t>
+            </a:r>
+          </a:p>
+        </p:txBody>
+      </p:sp>
     </p:spTree>
     <p:extLst>
       <p:ext uri="{BB962C8B-B14F-4D97-AF65-F5344CB8AC3E}">
@@ -14723,6 +14774,51 @@
                       </p:childTnLst>
                     </p:cTn>
                   </p:par>
+                  <p:par>
+                    <p:cTn id="7" fill="hold">
+                      <p:stCondLst>
+                        <p:cond delay="indefinite"/>
+                      </p:stCondLst>
+                      <p:childTnLst>
+                        <p:par>
+                          <p:cTn id="8" fill="hold">
+                            <p:stCondLst>
+                              <p:cond delay="0"/>
+                            </p:stCondLst>
+                            <p:childTnLst>
+                              <p:par>
+                                <p:cTn id="9" presetID="1" presetClass="entr" presetSubtype="0" fill="hold" grpId="0" nodeType="clickEffect">
+                                  <p:stCondLst>
+                                    <p:cond delay="0"/>
+                                  </p:stCondLst>
+                                  <p:childTnLst>
+                                    <p:set>
+                                      <p:cBhvr>
+                                        <p:cTn id="10" dur="1" fill="hold">
+                                          <p:stCondLst>
+                                            <p:cond delay="0"/>
+                                          </p:stCondLst>
+                                        </p:cTn>
+                                        <p:tgtEl>
+                                          <p:spTgt spid="8"/>
+                                        </p:tgtEl>
+                                        <p:attrNameLst>
+                                          <p:attrName>style.visibility</p:attrName>
+                                        </p:attrNameLst>
+                                      </p:cBhvr>
+                                      <p:to>
+                                        <p:strVal val="visible"/>
+                                      </p:to>
+                                    </p:set>
+                                  </p:childTnLst>
+                                </p:cTn>
+                              </p:par>
+                            </p:childTnLst>
+                          </p:cTn>
+                        </p:par>
+                      </p:childTnLst>
+                    </p:cTn>
+                  </p:par>
                 </p:childTnLst>
               </p:cTn>
               <p:prevCondLst>
@@ -14746,6 +14842,7 @@
     </p:tnLst>
     <p:bldLst>
       <p:bldP spid="7" grpId="0"/>
+      <p:bldP spid="8" grpId="0" animBg="1"/>
     </p:bldLst>
   </p:timing>
 </p:sld>

</xml_diff>